<commit_message>
Modified logo and PPT and some changes
</commit_message>
<xml_diff>
--- a/public/SCH_2026_Template.pptx
+++ b/public/SCH_2026_Template.pptx
@@ -1,6 +1,6 @@
 
 <file path=ppt/presentation.xml><?xml version="1.0" encoding="utf-8"?>
-<p:presentation xmlns:a="http://schemas.openxmlformats.org/drawingml/2006/main" xmlns:r="http://schemas.openxmlformats.org/officeDocument/2006/relationships" xmlns:p="http://schemas.openxmlformats.org/presentationml/2006/main" embedTrueTypeFonts="1">
+<p:presentation xmlns:a="http://schemas.openxmlformats.org/drawingml/2006/main" xmlns:r="http://schemas.openxmlformats.org/officeDocument/2006/relationships" xmlns:p="http://schemas.openxmlformats.org/presentationml/2006/main" embedTrueTypeFonts="1" saveSubsetFonts="1">
   <p:sldMasterIdLst>
     <p:sldMasterId id="2147483648" r:id="rId1"/>
   </p:sldMasterIdLst>
@@ -30,10 +30,6 @@
     <p:embeddedFont>
       <p:font typeface="Body Text" panose="020B0604020202020204" charset="0"/>
       <p:regular r:id="rId11"/>
-    </p:embeddedFont>
-    <p:embeddedFont>
-      <p:font typeface="Canva Sans Bold" panose="020B0604020202020204" charset="0"/>
-      <p:regular r:id="rId12"/>
     </p:embeddedFont>
   </p:embeddedFontLst>
   <p:defaultTextStyle>
@@ -330,7 +326,7 @@
             <a:fld id="{1D8BD707-D9CF-40AE-B4C6-C98DA3205C09}" type="datetimeFigureOut">
               <a:rPr lang="en-US" smtClean="0"/>
               <a:pPr/>
-              <a:t>12/29/2025</a:t>
+              <a:t>1/5/2026</a:t>
             </a:fld>
             <a:endParaRPr lang="en-US"/>
           </a:p>
@@ -495,7 +491,7 @@
             <a:fld id="{1D8BD707-D9CF-40AE-B4C6-C98DA3205C09}" type="datetimeFigureOut">
               <a:rPr lang="en-US" smtClean="0"/>
               <a:pPr/>
-              <a:t>12/29/2025</a:t>
+              <a:t>1/5/2026</a:t>
             </a:fld>
             <a:endParaRPr lang="en-US"/>
           </a:p>
@@ -670,7 +666,7 @@
             <a:fld id="{1D8BD707-D9CF-40AE-B4C6-C98DA3205C09}" type="datetimeFigureOut">
               <a:rPr lang="en-US" smtClean="0"/>
               <a:pPr/>
-              <a:t>12/29/2025</a:t>
+              <a:t>1/5/2026</a:t>
             </a:fld>
             <a:endParaRPr lang="en-US"/>
           </a:p>
@@ -835,7 +831,7 @@
             <a:fld id="{1D8BD707-D9CF-40AE-B4C6-C98DA3205C09}" type="datetimeFigureOut">
               <a:rPr lang="en-US" smtClean="0"/>
               <a:pPr/>
-              <a:t>12/29/2025</a:t>
+              <a:t>1/5/2026</a:t>
             </a:fld>
             <a:endParaRPr lang="en-US"/>
           </a:p>
@@ -1077,7 +1073,7 @@
             <a:fld id="{1D8BD707-D9CF-40AE-B4C6-C98DA3205C09}" type="datetimeFigureOut">
               <a:rPr lang="en-US" smtClean="0"/>
               <a:pPr/>
-              <a:t>12/29/2025</a:t>
+              <a:t>1/5/2026</a:t>
             </a:fld>
             <a:endParaRPr lang="en-US"/>
           </a:p>
@@ -1359,7 +1355,7 @@
             <a:fld id="{1D8BD707-D9CF-40AE-B4C6-C98DA3205C09}" type="datetimeFigureOut">
               <a:rPr lang="en-US" smtClean="0"/>
               <a:pPr/>
-              <a:t>12/29/2025</a:t>
+              <a:t>1/5/2026</a:t>
             </a:fld>
             <a:endParaRPr lang="en-US"/>
           </a:p>
@@ -1775,7 +1771,7 @@
             <a:fld id="{1D8BD707-D9CF-40AE-B4C6-C98DA3205C09}" type="datetimeFigureOut">
               <a:rPr lang="en-US" smtClean="0"/>
               <a:pPr/>
-              <a:t>12/29/2025</a:t>
+              <a:t>1/5/2026</a:t>
             </a:fld>
             <a:endParaRPr lang="en-US"/>
           </a:p>
@@ -1889,7 +1885,7 @@
             <a:fld id="{1D8BD707-D9CF-40AE-B4C6-C98DA3205C09}" type="datetimeFigureOut">
               <a:rPr lang="en-US" smtClean="0"/>
               <a:pPr/>
-              <a:t>12/29/2025</a:t>
+              <a:t>1/5/2026</a:t>
             </a:fld>
             <a:endParaRPr lang="en-US"/>
           </a:p>
@@ -1981,7 +1977,7 @@
             <a:fld id="{1D8BD707-D9CF-40AE-B4C6-C98DA3205C09}" type="datetimeFigureOut">
               <a:rPr lang="en-US" smtClean="0"/>
               <a:pPr/>
-              <a:t>12/29/2025</a:t>
+              <a:t>1/5/2026</a:t>
             </a:fld>
             <a:endParaRPr lang="en-US"/>
           </a:p>
@@ -2253,7 +2249,7 @@
             <a:fld id="{1D8BD707-D9CF-40AE-B4C6-C98DA3205C09}" type="datetimeFigureOut">
               <a:rPr lang="en-US" smtClean="0"/>
               <a:pPr/>
-              <a:t>12/29/2025</a:t>
+              <a:t>1/5/2026</a:t>
             </a:fld>
             <a:endParaRPr lang="en-US"/>
           </a:p>
@@ -2502,7 +2498,7 @@
             <a:fld id="{1D8BD707-D9CF-40AE-B4C6-C98DA3205C09}" type="datetimeFigureOut">
               <a:rPr lang="en-US" smtClean="0"/>
               <a:pPr/>
-              <a:t>12/29/2025</a:t>
+              <a:t>1/5/2026</a:t>
             </a:fld>
             <a:endParaRPr lang="en-US"/>
           </a:p>
@@ -2710,7 +2706,7 @@
             <a:fld id="{1D8BD707-D9CF-40AE-B4C6-C98DA3205C09}" type="datetimeFigureOut">
               <a:rPr lang="en-US" smtClean="0"/>
               <a:pPr/>
-              <a:t>12/29/2025</a:t>
+              <a:t>1/5/2026</a:t>
             </a:fld>
             <a:endParaRPr lang="en-US"/>
           </a:p>
@@ -3109,7 +3105,7 @@
         </p:nvSpPr>
         <p:spPr>
           <a:xfrm>
-            <a:off x="5486400" y="9722474"/>
+            <a:off x="6323003" y="9596169"/>
             <a:ext cx="2743795" cy="692808"/>
           </a:xfrm>
           <a:custGeom>
@@ -3152,6 +3148,13 @@
             </a:stretch>
           </a:blipFill>
         </p:spPr>
+        <p:txBody>
+          <a:bodyPr/>
+          <a:lstStyle/>
+          <a:p>
+            <a:endParaRPr lang="en-IN" dirty="0"/>
+          </a:p>
+        </p:txBody>
       </p:sp>
       <p:grpSp>
         <p:nvGrpSpPr>
@@ -3161,7 +3164,7 @@
         </p:nvGrpSpPr>
         <p:grpSpPr>
           <a:xfrm>
-            <a:off x="-844715" y="9722474"/>
+            <a:off x="0" y="9583212"/>
             <a:ext cx="6708766" cy="718723"/>
             <a:chOff x="0" y="0"/>
             <a:chExt cx="1766918" cy="189293"/>
@@ -3248,7 +3251,7 @@
         <p:grpSpPr>
           <a:xfrm>
             <a:off x="16929528" y="6743571"/>
-            <a:ext cx="1579880" cy="496640"/>
+            <a:ext cx="1358472" cy="496640"/>
             <a:chOff x="0" y="0"/>
             <a:chExt cx="354547" cy="111453"/>
           </a:xfrm>
@@ -3337,8 +3340,8 @@
         </p:nvGrpSpPr>
         <p:grpSpPr>
           <a:xfrm>
-            <a:off x="-172053" y="2345722"/>
-            <a:ext cx="2681721" cy="289923"/>
+            <a:off x="0" y="2345722"/>
+            <a:ext cx="2509668" cy="368256"/>
             <a:chOff x="0" y="0"/>
             <a:chExt cx="601815" cy="65063"/>
           </a:xfrm>
@@ -3483,144 +3486,6 @@
             <a:xfrm>
               <a:off x="0" y="-38100"/>
               <a:ext cx="116742" cy="149553"/>
-            </a:xfrm>
-            <a:prstGeom prst="rect">
-              <a:avLst/>
-            </a:prstGeom>
-          </p:spPr>
-          <p:txBody>
-            <a:bodyPr lIns="50800" tIns="50800" rIns="50800" bIns="50800" rtlCol="0" anchor="ctr"/>
-            <a:lstStyle/>
-            <a:p>
-              <a:pPr algn="ctr">
-                <a:lnSpc>
-                  <a:spcPts val="2659"/>
-                </a:lnSpc>
-              </a:pPr>
-              <a:endParaRPr/>
-            </a:p>
-          </p:txBody>
-        </p:sp>
-      </p:grpSp>
-      <p:sp>
-        <p:nvSpPr>
-          <p:cNvPr id="15" name="Freeform 15"/>
-          <p:cNvSpPr/>
-          <p:nvPr/>
-        </p:nvSpPr>
-        <p:spPr>
-          <a:xfrm>
-            <a:off x="5486400" y="9722474"/>
-            <a:ext cx="2743795" cy="692808"/>
-          </a:xfrm>
-          <a:custGeom>
-            <a:avLst/>
-            <a:gdLst/>
-            <a:ahLst/>
-            <a:cxnLst/>
-            <a:rect l="l" t="t" r="r" b="b"/>
-            <a:pathLst>
-              <a:path w="2743795" h="692808">
-                <a:moveTo>
-                  <a:pt x="0" y="0"/>
-                </a:moveTo>
-                <a:lnTo>
-                  <a:pt x="2743795" y="0"/>
-                </a:lnTo>
-                <a:lnTo>
-                  <a:pt x="2743795" y="692808"/>
-                </a:lnTo>
-                <a:lnTo>
-                  <a:pt x="0" y="692808"/>
-                </a:lnTo>
-                <a:lnTo>
-                  <a:pt x="0" y="0"/>
-                </a:lnTo>
-                <a:close/>
-              </a:path>
-            </a:pathLst>
-          </a:custGeom>
-          <a:blipFill>
-            <a:blip r:embed="rId2">
-              <a:extLst>
-                <a:ext uri="{96DAC541-7B7A-43D3-8B79-37D633B846F1}">
-                  <asvg:svgBlip xmlns:asvg="http://schemas.microsoft.com/office/drawing/2016/SVG/main" r:embed="rId3"/>
-                </a:ext>
-              </a:extLst>
-            </a:blip>
-            <a:stretch>
-              <a:fillRect/>
-            </a:stretch>
-          </a:blipFill>
-        </p:spPr>
-      </p:sp>
-      <p:grpSp>
-        <p:nvGrpSpPr>
-          <p:cNvPr id="16" name="Group 16"/>
-          <p:cNvGrpSpPr/>
-          <p:nvPr/>
-        </p:nvGrpSpPr>
-        <p:grpSpPr>
-          <a:xfrm>
-            <a:off x="0" y="9722474"/>
-            <a:ext cx="5864051" cy="628227"/>
-            <a:chOff x="0" y="0"/>
-            <a:chExt cx="1766918" cy="189293"/>
-          </a:xfrm>
-        </p:grpSpPr>
-        <p:sp>
-          <p:nvSpPr>
-            <p:cNvPr id="17" name="Freeform 17"/>
-            <p:cNvSpPr/>
-            <p:nvPr/>
-          </p:nvSpPr>
-          <p:spPr>
-            <a:xfrm>
-              <a:off x="0" y="0"/>
-              <a:ext cx="1766918" cy="189293"/>
-            </a:xfrm>
-            <a:custGeom>
-              <a:avLst/>
-              <a:gdLst/>
-              <a:ahLst/>
-              <a:cxnLst/>
-              <a:rect l="l" t="t" r="r" b="b"/>
-              <a:pathLst>
-                <a:path w="1766918" h="189293">
-                  <a:moveTo>
-                    <a:pt x="203200" y="0"/>
-                  </a:moveTo>
-                  <a:lnTo>
-                    <a:pt x="1766918" y="0"/>
-                  </a:lnTo>
-                  <a:lnTo>
-                    <a:pt x="1563718" y="189293"/>
-                  </a:lnTo>
-                  <a:lnTo>
-                    <a:pt x="0" y="189293"/>
-                  </a:lnTo>
-                  <a:lnTo>
-                    <a:pt x="203200" y="0"/>
-                  </a:lnTo>
-                  <a:close/>
-                </a:path>
-              </a:pathLst>
-            </a:custGeom>
-            <a:solidFill>
-              <a:srgbClr val="FFFFFF"/>
-            </a:solidFill>
-          </p:spPr>
-        </p:sp>
-        <p:sp>
-          <p:nvSpPr>
-            <p:cNvPr id="18" name="TextBox 18"/>
-            <p:cNvSpPr txBox="1"/>
-            <p:nvPr/>
-          </p:nvSpPr>
-          <p:spPr>
-            <a:xfrm>
-              <a:off x="101600" y="-38100"/>
-              <a:ext cx="1563718" cy="227393"/>
             </a:xfrm>
             <a:prstGeom prst="rect">
               <a:avLst/>
@@ -3989,6 +3854,13 @@
               <a:miter/>
             </a:ln>
           </p:spPr>
+          <p:txBody>
+            <a:bodyPr/>
+            <a:lstStyle/>
+            <a:p>
+              <a:endParaRPr lang="en-IN" dirty="0"/>
+            </a:p>
+          </p:txBody>
         </p:sp>
         <p:sp>
           <p:nvSpPr>
@@ -4075,8 +3947,8 @@
         </p:nvSpPr>
         <p:spPr>
           <a:xfrm>
-            <a:off x="2141635" y="-53623"/>
-            <a:ext cx="3553396" cy="3553396"/>
+            <a:off x="2909577" y="22556"/>
+            <a:ext cx="3813140" cy="3813140"/>
           </a:xfrm>
           <a:custGeom>
             <a:avLst/>
@@ -4085,18 +3957,18 @@
             <a:cxnLst/>
             <a:rect l="l" t="t" r="r" b="b"/>
             <a:pathLst>
-              <a:path w="3553396" h="3553396">
+              <a:path w="3813140" h="3813140">
                 <a:moveTo>
                   <a:pt x="0" y="0"/>
                 </a:moveTo>
                 <a:lnTo>
-                  <a:pt x="3553395" y="0"/>
+                  <a:pt x="3813140" y="0"/>
                 </a:lnTo>
                 <a:lnTo>
-                  <a:pt x="3553395" y="3553396"/>
+                  <a:pt x="3813140" y="3813139"/>
                 </a:lnTo>
                 <a:lnTo>
-                  <a:pt x="0" y="3553396"/>
+                  <a:pt x="0" y="3813139"/>
                 </a:lnTo>
                 <a:lnTo>
                   <a:pt x="0" y="0"/>
@@ -4121,7 +3993,7 @@
         </p:nvSpPr>
         <p:spPr>
           <a:xfrm>
-            <a:off x="2442473" y="4106208"/>
+            <a:off x="2637410" y="4107494"/>
             <a:ext cx="2306479" cy="560559"/>
           </a:xfrm>
           <a:prstGeom prst="rect">
@@ -4165,8 +4037,8 @@
         </p:nvSpPr>
         <p:spPr>
           <a:xfrm>
-            <a:off x="9675738" y="5021475"/>
-            <a:ext cx="3964059" cy="564257"/>
+            <a:off x="9091750" y="5143500"/>
+            <a:ext cx="3811657" cy="564257"/>
           </a:xfrm>
           <a:prstGeom prst="rect">
             <a:avLst/>
@@ -4209,7 +4081,7 @@
         </p:nvSpPr>
         <p:spPr>
           <a:xfrm>
-            <a:off x="8850754" y="4135650"/>
+            <a:off x="9144000" y="3969045"/>
             <a:ext cx="1649968" cy="560559"/>
           </a:xfrm>
           <a:prstGeom prst="rect">
@@ -4231,7 +4103,7 @@
               </a:spcBef>
             </a:pPr>
             <a:r>
-              <a:rPr lang="en-US" sz="2828" b="1" u="none" strike="noStrike" dirty="0">
+              <a:rPr lang="en-US" sz="2828" b="1" u="none" strike="noStrike">
                 <a:solidFill>
                   <a:srgbClr val="FFFFFF"/>
                 </a:solidFill>
@@ -4253,8 +4125,8 @@
         </p:nvSpPr>
         <p:spPr>
           <a:xfrm>
-            <a:off x="3563867" y="6787396"/>
-            <a:ext cx="2802719" cy="1038746"/>
+            <a:off x="2452709" y="6044757"/>
+            <a:ext cx="1890690" cy="743793"/>
           </a:xfrm>
           <a:prstGeom prst="rect">
             <a:avLst/>
@@ -4268,14 +4140,14 @@
           <a:p>
             <a:pPr marL="0" lvl="0" indent="0" algn="l">
               <a:lnSpc>
-                <a:spcPts val="8094"/>
+                <a:spcPts val="5825"/>
               </a:lnSpc>
               <a:spcBef>
                 <a:spcPct val="0"/>
               </a:spcBef>
             </a:pPr>
             <a:r>
-              <a:rPr lang="en-US" sz="6179" b="1" dirty="0">
+              <a:rPr lang="en-US" sz="4446" b="1" dirty="0">
                 <a:solidFill>
                   <a:srgbClr val="39FF14"/>
                 </a:solidFill>
@@ -4291,14 +4163,55 @@
       </p:sp>
       <p:sp>
         <p:nvSpPr>
-          <p:cNvPr id="39" name="AutoShape 39"/>
+          <p:cNvPr id="39" name="TextBox 39"/>
+          <p:cNvSpPr txBox="1"/>
+          <p:nvPr/>
+        </p:nvSpPr>
+        <p:spPr>
+          <a:xfrm>
+            <a:off x="6060092" y="706228"/>
+            <a:ext cx="6023130" cy="2717345"/>
+          </a:xfrm>
+          <a:prstGeom prst="rect">
+            <a:avLst/>
+          </a:prstGeom>
+        </p:spPr>
+        <p:txBody>
+          <a:bodyPr lIns="0" tIns="0" rIns="0" bIns="0" rtlCol="0" anchor="t">
+            <a:spAutoFit/>
+          </a:bodyPr>
+          <a:lstStyle/>
+          <a:p>
+            <a:pPr algn="ctr">
+              <a:lnSpc>
+                <a:spcPts val="20336"/>
+              </a:lnSpc>
+            </a:pPr>
+            <a:r>
+              <a:rPr lang="en-US" sz="20336" b="1">
+                <a:solidFill>
+                  <a:srgbClr val="39FF14"/>
+                </a:solidFill>
+                <a:latin typeface="Big Shoulders Display Bold"/>
+                <a:ea typeface="Big Shoulders Display Bold"/>
+                <a:cs typeface="Big Shoulders Display Bold"/>
+                <a:sym typeface="Big Shoulders Display Bold"/>
+              </a:rPr>
+              <a:t>SCH ‘</a:t>
+            </a:r>
+          </a:p>
+        </p:txBody>
+      </p:sp>
+      <p:sp>
+        <p:nvSpPr>
+          <p:cNvPr id="40" name="AutoShape 40"/>
           <p:cNvSpPr/>
           <p:nvPr/>
         </p:nvSpPr>
         <p:spPr>
           <a:xfrm>
-            <a:off x="2141635" y="5940620"/>
-            <a:ext cx="6492240" cy="0"/>
+            <a:off x="2103792" y="5921570"/>
+            <a:ext cx="6436045" cy="0"/>
           </a:xfrm>
           <a:prstGeom prst="line">
             <a:avLst/>
@@ -4315,55 +4228,58 @@
       </p:sp>
       <p:sp>
         <p:nvSpPr>
-          <p:cNvPr id="40" name="TextBox 40"/>
+          <p:cNvPr id="41" name="TextBox 41"/>
           <p:cNvSpPr txBox="1"/>
           <p:nvPr/>
         </p:nvSpPr>
         <p:spPr>
           <a:xfrm>
-            <a:off x="2431100" y="5072085"/>
-            <a:ext cx="2824332" cy="643766"/>
+            <a:off x="2005198" y="5091023"/>
+            <a:ext cx="6224184" cy="583864"/>
           </a:xfrm>
           <a:prstGeom prst="rect">
             <a:avLst/>
           </a:prstGeom>
         </p:spPr>
         <p:txBody>
-          <a:bodyPr wrap="square" lIns="0" tIns="0" rIns="0" bIns="0" rtlCol="0" anchor="t">
+          <a:bodyPr lIns="0" tIns="0" rIns="0" bIns="0" rtlCol="0" anchor="t">
             <a:spAutoFit/>
           </a:bodyPr>
           <a:lstStyle/>
           <a:p>
             <a:pPr algn="ctr">
               <a:lnSpc>
-                <a:spcPts val="5290"/>
+                <a:spcPts val="4043"/>
               </a:lnSpc>
+              <a:spcBef>
+                <a:spcPct val="0"/>
+              </a:spcBef>
             </a:pPr>
             <a:r>
-              <a:rPr lang="en-US" sz="3779" b="1" dirty="0">
+              <a:rPr lang="en-US" sz="2888" b="1" dirty="0">
                 <a:solidFill>
                   <a:srgbClr val="FFFFFF"/>
                 </a:solidFill>
-                <a:latin typeface="Canva Sans Bold"/>
-                <a:ea typeface="Canva Sans Bold"/>
-                <a:cs typeface="Canva Sans Bold"/>
-                <a:sym typeface="Canva Sans Bold"/>
+                <a:latin typeface="29LT Bukra Bold"/>
+                <a:ea typeface="29LT Bukra Bold"/>
+                <a:cs typeface="29LT Bukra Bold"/>
+                <a:sym typeface="29LT Bukra Bold"/>
               </a:rPr>
-              <a:t>DEPT NAME</a:t>
-            </a:r>
-          </a:p>
-        </p:txBody>
-      </p:sp>
-      <p:sp>
-        <p:nvSpPr>
-          <p:cNvPr id="41" name="TextBox 41"/>
+              <a:t>PROBLEM STATEMENT ID</a:t>
+            </a:r>
+          </a:p>
+        </p:txBody>
+      </p:sp>
+      <p:sp>
+        <p:nvSpPr>
+          <p:cNvPr id="42" name="TextBox 42"/>
           <p:cNvSpPr txBox="1"/>
           <p:nvPr/>
         </p:nvSpPr>
         <p:spPr>
           <a:xfrm>
-            <a:off x="5084399" y="725278"/>
-            <a:ext cx="6023130" cy="2717345"/>
+            <a:off x="9071657" y="1265551"/>
+            <a:ext cx="9140758" cy="1993899"/>
           </a:xfrm>
           <a:prstGeom prst="rect">
             <a:avLst/>
@@ -4377,52 +4293,11 @@
           <a:p>
             <a:pPr algn="ctr">
               <a:lnSpc>
-                <a:spcPts val="20336"/>
+                <a:spcPts val="13999"/>
               </a:lnSpc>
             </a:pPr>
             <a:r>
-              <a:rPr lang="en-US" sz="20336" b="1">
-                <a:solidFill>
-                  <a:srgbClr val="39FF14"/>
-                </a:solidFill>
-                <a:latin typeface="Big Shoulders Display Bold"/>
-                <a:ea typeface="Big Shoulders Display Bold"/>
-                <a:cs typeface="Big Shoulders Display Bold"/>
-                <a:sym typeface="Big Shoulders Display Bold"/>
-              </a:rPr>
-              <a:t>SCH ‘</a:t>
-            </a:r>
-          </a:p>
-        </p:txBody>
-      </p:sp>
-      <p:sp>
-        <p:nvSpPr>
-          <p:cNvPr id="42" name="TextBox 42"/>
-          <p:cNvSpPr txBox="1"/>
-          <p:nvPr/>
-        </p:nvSpPr>
-        <p:spPr>
-          <a:xfrm>
-            <a:off x="9521249" y="806389"/>
-            <a:ext cx="5846935" cy="2636234"/>
-          </a:xfrm>
-          <a:prstGeom prst="rect">
-            <a:avLst/>
-          </a:prstGeom>
-        </p:spPr>
-        <p:txBody>
-          <a:bodyPr lIns="0" tIns="0" rIns="0" bIns="0" rtlCol="0" anchor="t">
-            <a:spAutoFit/>
-          </a:bodyPr>
-          <a:lstStyle/>
-          <a:p>
-            <a:pPr algn="ctr">
-              <a:lnSpc>
-                <a:spcPts val="19741"/>
-              </a:lnSpc>
-            </a:pPr>
-            <a:r>
-              <a:rPr lang="en-US" sz="19741" b="1">
+              <a:rPr lang="en-US" sz="17499" b="1" spc="1312">
                 <a:solidFill>
                   <a:srgbClr val="FFFFFF"/>
                 </a:solidFill>
@@ -4667,7 +4542,7 @@
         </p:nvSpPr>
         <p:spPr>
           <a:xfrm>
-            <a:off x="16124899" y="9720677"/>
+            <a:off x="16152803" y="9700319"/>
             <a:ext cx="2242863" cy="566323"/>
           </a:xfrm>
           <a:custGeom>
@@ -4719,7 +4594,7 @@
         </p:nvGrpSpPr>
         <p:grpSpPr>
           <a:xfrm>
-            <a:off x="9793785" y="9720677"/>
+            <a:off x="9829800" y="9568277"/>
             <a:ext cx="6708766" cy="718723"/>
             <a:chOff x="0" y="0"/>
             <a:chExt cx="1766918" cy="189293"/>
@@ -5019,8 +4894,8 @@
         </p:nvSpPr>
         <p:spPr>
           <a:xfrm>
-            <a:off x="15942278" y="-2914"/>
-            <a:ext cx="2345722" cy="2345722"/>
+            <a:off x="15895863" y="0"/>
+            <a:ext cx="2321737" cy="2321737"/>
           </a:xfrm>
           <a:custGeom>
             <a:avLst/>
@@ -5029,18 +4904,18 @@
             <a:cxnLst/>
             <a:rect l="l" t="t" r="r" b="b"/>
             <a:pathLst>
-              <a:path w="2345722" h="2345722">
+              <a:path w="2321737" h="2321737">
                 <a:moveTo>
                   <a:pt x="0" y="0"/>
                 </a:moveTo>
                 <a:lnTo>
-                  <a:pt x="2345722" y="0"/>
+                  <a:pt x="2321737" y="0"/>
                 </a:lnTo>
                 <a:lnTo>
-                  <a:pt x="2345722" y="2345722"/>
+                  <a:pt x="2321737" y="2321737"/>
                 </a:lnTo>
                 <a:lnTo>
-                  <a:pt x="0" y="2345722"/>
+                  <a:pt x="0" y="2321737"/>
                 </a:lnTo>
                 <a:lnTo>
                   <a:pt x="0" y="0"/>
@@ -5555,7 +5430,7 @@
         </p:nvGrpSpPr>
         <p:grpSpPr>
           <a:xfrm>
-            <a:off x="9793785" y="9720677"/>
+            <a:off x="9829800" y="9568277"/>
             <a:ext cx="6708766" cy="718723"/>
             <a:chOff x="0" y="0"/>
             <a:chExt cx="1766918" cy="189293"/>
@@ -5855,8 +5730,8 @@
         </p:nvSpPr>
         <p:spPr>
           <a:xfrm>
-            <a:off x="15883871" y="0"/>
-            <a:ext cx="2345722" cy="2345722"/>
+            <a:off x="15895863" y="0"/>
+            <a:ext cx="2321737" cy="2321737"/>
           </a:xfrm>
           <a:custGeom>
             <a:avLst/>
@@ -5865,18 +5740,18 @@
             <a:cxnLst/>
             <a:rect l="l" t="t" r="r" b="b"/>
             <a:pathLst>
-              <a:path w="2345722" h="2345722">
+              <a:path w="2321737" h="2321737">
                 <a:moveTo>
                   <a:pt x="0" y="0"/>
                 </a:moveTo>
                 <a:lnTo>
-                  <a:pt x="2345722" y="0"/>
+                  <a:pt x="2321737" y="0"/>
                 </a:lnTo>
                 <a:lnTo>
-                  <a:pt x="2345722" y="2345722"/>
+                  <a:pt x="2321737" y="2321737"/>
                 </a:lnTo>
                 <a:lnTo>
-                  <a:pt x="0" y="2345722"/>
+                  <a:pt x="0" y="2321737"/>
                 </a:lnTo>
                 <a:lnTo>
                   <a:pt x="0" y="0"/>
@@ -6451,14 +6326,184 @@
       </p:grpSp>
       <p:sp>
         <p:nvSpPr>
-          <p:cNvPr id="19" name="Freeform 19"/>
+          <p:cNvPr id="19" name="TextBox 19"/>
+          <p:cNvSpPr txBox="1"/>
+          <p:nvPr/>
+        </p:nvSpPr>
+        <p:spPr>
+          <a:xfrm>
+            <a:off x="1028700" y="3227263"/>
+            <a:ext cx="7858737" cy="417698"/>
+          </a:xfrm>
+          <a:prstGeom prst="rect">
+            <a:avLst/>
+          </a:prstGeom>
+        </p:spPr>
+        <p:txBody>
+          <a:bodyPr lIns="0" tIns="0" rIns="0" bIns="0" rtlCol="0" anchor="t">
+            <a:spAutoFit/>
+          </a:bodyPr>
+          <a:lstStyle/>
+          <a:p>
+            <a:pPr algn="just">
+              <a:lnSpc>
+                <a:spcPts val="3421"/>
+              </a:lnSpc>
+            </a:pPr>
+            <a:r>
+              <a:rPr lang="en-US" sz="2592">
+                <a:solidFill>
+                  <a:srgbClr val="FFFFFF"/>
+                </a:solidFill>
+                <a:latin typeface="Body Text"/>
+                <a:ea typeface="Body Text"/>
+                <a:cs typeface="Body Text"/>
+                <a:sym typeface="Body Text"/>
+              </a:rPr>
+              <a:t>Detailed solution for your problem statement</a:t>
+            </a:r>
+          </a:p>
+        </p:txBody>
+      </p:sp>
+      <p:sp>
+        <p:nvSpPr>
+          <p:cNvPr id="20" name="TextBox 20"/>
+          <p:cNvSpPr txBox="1"/>
+          <p:nvPr/>
+        </p:nvSpPr>
+        <p:spPr>
+          <a:xfrm>
+            <a:off x="765143" y="752475"/>
+            <a:ext cx="9932818" cy="1222874"/>
+          </a:xfrm>
+          <a:prstGeom prst="rect">
+            <a:avLst/>
+          </a:prstGeom>
+        </p:spPr>
+        <p:txBody>
+          <a:bodyPr lIns="0" tIns="0" rIns="0" bIns="0" rtlCol="0" anchor="t">
+            <a:spAutoFit/>
+          </a:bodyPr>
+          <a:lstStyle/>
+          <a:p>
+            <a:pPr algn="l">
+              <a:lnSpc>
+                <a:spcPts val="8139"/>
+              </a:lnSpc>
+            </a:pPr>
+            <a:r>
+              <a:rPr lang="en-US" sz="6213" b="1">
+                <a:solidFill>
+                  <a:srgbClr val="FFFFFF"/>
+                </a:solidFill>
+                <a:latin typeface="29LT Bukra Bold"/>
+                <a:ea typeface="29LT Bukra Bold"/>
+                <a:cs typeface="29LT Bukra Bold"/>
+                <a:sym typeface="29LT Bukra Bold"/>
+              </a:rPr>
+              <a:t>PROPOSED SOLUTION</a:t>
+            </a:r>
+          </a:p>
+        </p:txBody>
+      </p:sp>
+      <p:sp>
+        <p:nvSpPr>
+          <p:cNvPr id="21" name="TextBox 21"/>
+          <p:cNvSpPr txBox="1"/>
+          <p:nvPr/>
+        </p:nvSpPr>
+        <p:spPr>
+          <a:xfrm>
+            <a:off x="13323735" y="1786572"/>
+            <a:ext cx="1433134" cy="323215"/>
+          </a:xfrm>
+          <a:prstGeom prst="rect">
+            <a:avLst/>
+          </a:prstGeom>
+        </p:spPr>
+        <p:txBody>
+          <a:bodyPr lIns="0" tIns="0" rIns="0" bIns="0" rtlCol="0" anchor="t">
+            <a:spAutoFit/>
+          </a:bodyPr>
+          <a:lstStyle/>
+          <a:p>
+            <a:pPr algn="ctr">
+              <a:lnSpc>
+                <a:spcPts val="2659"/>
+              </a:lnSpc>
+              <a:spcBef>
+                <a:spcPct val="0"/>
+              </a:spcBef>
+            </a:pPr>
+            <a:r>
+              <a:rPr lang="en-US" sz="1899">
+                <a:solidFill>
+                  <a:srgbClr val="000000"/>
+                </a:solidFill>
+                <a:latin typeface="Anton"/>
+                <a:ea typeface="Anton"/>
+                <a:cs typeface="Anton"/>
+                <a:sym typeface="Anton"/>
+              </a:rPr>
+              <a:t>BLOCK DIAGRAM</a:t>
+            </a:r>
+          </a:p>
+        </p:txBody>
+      </p:sp>
+      <p:sp>
+        <p:nvSpPr>
+          <p:cNvPr id="22" name="TextBox 22"/>
+          <p:cNvSpPr txBox="1"/>
+          <p:nvPr/>
+        </p:nvSpPr>
+        <p:spPr>
+          <a:xfrm>
+            <a:off x="13481761" y="2008664"/>
+            <a:ext cx="1386721" cy="323215"/>
+          </a:xfrm>
+          <a:prstGeom prst="rect">
+            <a:avLst/>
+          </a:prstGeom>
+        </p:spPr>
+        <p:txBody>
+          <a:bodyPr lIns="0" tIns="0" rIns="0" bIns="0" rtlCol="0" anchor="t">
+            <a:spAutoFit/>
+          </a:bodyPr>
+          <a:lstStyle/>
+          <a:p>
+            <a:pPr algn="ctr">
+              <a:lnSpc>
+                <a:spcPts val="2659"/>
+              </a:lnSpc>
+              <a:spcBef>
+                <a:spcPct val="0"/>
+              </a:spcBef>
+            </a:pPr>
+            <a:r>
+              <a:rPr lang="en-US" sz="1899" dirty="0">
+                <a:solidFill>
+                  <a:srgbClr val="FFFFFF"/>
+                </a:solidFill>
+                <a:latin typeface="Anton"/>
+                <a:ea typeface="Anton"/>
+                <a:cs typeface="Anton"/>
+                <a:sym typeface="Anton"/>
+              </a:rPr>
+              <a:t>Block Diagram</a:t>
+            </a:r>
+          </a:p>
+        </p:txBody>
+      </p:sp>
+      <p:sp>
+        <p:nvSpPr>
+          <p:cNvPr id="23" name="Freeform 23"/>
           <p:cNvSpPr/>
           <p:nvPr/>
         </p:nvSpPr>
         <p:spPr>
           <a:xfrm>
-            <a:off x="15942278" y="-13843"/>
-            <a:ext cx="2345722" cy="2345722"/>
+            <a:off x="15895863" y="0"/>
+            <a:ext cx="2321737" cy="2321737"/>
           </a:xfrm>
           <a:custGeom>
             <a:avLst/>
@@ -6467,18 +6512,18 @@
             <a:cxnLst/>
             <a:rect l="l" t="t" r="r" b="b"/>
             <a:pathLst>
-              <a:path w="2345722" h="2345722">
+              <a:path w="2321737" h="2321737">
                 <a:moveTo>
                   <a:pt x="0" y="0"/>
                 </a:moveTo>
                 <a:lnTo>
-                  <a:pt x="2345722" y="0"/>
+                  <a:pt x="2321737" y="0"/>
                 </a:lnTo>
                 <a:lnTo>
-                  <a:pt x="2345722" y="2345722"/>
+                  <a:pt x="2321737" y="2321737"/>
                 </a:lnTo>
                 <a:lnTo>
-                  <a:pt x="0" y="2345722"/>
+                  <a:pt x="0" y="2321737"/>
                 </a:lnTo>
                 <a:lnTo>
                   <a:pt x="0" y="0"/>
@@ -6495,176 +6540,42 @@
           </a:blipFill>
         </p:spPr>
       </p:sp>
-      <p:sp>
-        <p:nvSpPr>
-          <p:cNvPr id="20" name="TextBox 20"/>
-          <p:cNvSpPr txBox="1"/>
+      <p:pic>
+        <p:nvPicPr>
+          <p:cNvPr id="25" name="Picture 24">
+            <a:extLst>
+              <a:ext uri="{FF2B5EF4-FFF2-40B4-BE49-F238E27FC236}">
+                <a16:creationId xmlns:a16="http://schemas.microsoft.com/office/drawing/2014/main" id="{EBBC0A1B-7695-050A-3BE6-1322746C6236}"/>
+              </a:ext>
+            </a:extLst>
+          </p:cNvPr>
+          <p:cNvPicPr>
+            <a:picLocks noChangeAspect="1"/>
+          </p:cNvPicPr>
           <p:nvPr/>
-        </p:nvSpPr>
+        </p:nvPicPr>
+        <p:blipFill>
+          <a:blip r:embed="rId3">
+            <a:extLst>
+              <a:ext uri="{28A0092B-C50C-407E-A947-70E740481C1C}">
+                <a14:useLocalDpi xmlns:a14="http://schemas.microsoft.com/office/drawing/2010/main" val="0"/>
+              </a:ext>
+            </a:extLst>
+          </a:blip>
+          <a:stretch>
+            <a:fillRect/>
+          </a:stretch>
+        </p:blipFill>
         <p:spPr>
           <a:xfrm>
-            <a:off x="1028700" y="3227263"/>
-            <a:ext cx="7858737" cy="417698"/>
+            <a:off x="10333097" y="2871062"/>
+            <a:ext cx="7684047" cy="5709122"/>
           </a:xfrm>
           <a:prstGeom prst="rect">
             <a:avLst/>
           </a:prstGeom>
         </p:spPr>
-        <p:txBody>
-          <a:bodyPr lIns="0" tIns="0" rIns="0" bIns="0" rtlCol="0" anchor="t">
-            <a:spAutoFit/>
-          </a:bodyPr>
-          <a:lstStyle/>
-          <a:p>
-            <a:pPr algn="just">
-              <a:lnSpc>
-                <a:spcPts val="3421"/>
-              </a:lnSpc>
-            </a:pPr>
-            <a:r>
-              <a:rPr lang="en-US" sz="2592">
-                <a:solidFill>
-                  <a:srgbClr val="FFFFFF"/>
-                </a:solidFill>
-                <a:latin typeface="Body Text"/>
-                <a:ea typeface="Body Text"/>
-                <a:cs typeface="Body Text"/>
-                <a:sym typeface="Body Text"/>
-              </a:rPr>
-              <a:t>Detailed solution for your problem statement</a:t>
-            </a:r>
-          </a:p>
-        </p:txBody>
-      </p:sp>
-      <p:sp>
-        <p:nvSpPr>
-          <p:cNvPr id="21" name="TextBox 21"/>
-          <p:cNvSpPr txBox="1"/>
-          <p:nvPr/>
-        </p:nvSpPr>
-        <p:spPr>
-          <a:xfrm>
-            <a:off x="765143" y="752475"/>
-            <a:ext cx="9932818" cy="1222874"/>
-          </a:xfrm>
-          <a:prstGeom prst="rect">
-            <a:avLst/>
-          </a:prstGeom>
-        </p:spPr>
-        <p:txBody>
-          <a:bodyPr lIns="0" tIns="0" rIns="0" bIns="0" rtlCol="0" anchor="t">
-            <a:spAutoFit/>
-          </a:bodyPr>
-          <a:lstStyle/>
-          <a:p>
-            <a:pPr algn="l">
-              <a:lnSpc>
-                <a:spcPts val="8139"/>
-              </a:lnSpc>
-            </a:pPr>
-            <a:r>
-              <a:rPr lang="en-US" sz="6213" b="1">
-                <a:solidFill>
-                  <a:srgbClr val="FFFFFF"/>
-                </a:solidFill>
-                <a:latin typeface="29LT Bukra Bold"/>
-                <a:ea typeface="29LT Bukra Bold"/>
-                <a:cs typeface="29LT Bukra Bold"/>
-                <a:sym typeface="29LT Bukra Bold"/>
-              </a:rPr>
-              <a:t>PROPOSED SOLUTION</a:t>
-            </a:r>
-          </a:p>
-        </p:txBody>
-      </p:sp>
-      <p:sp>
-        <p:nvSpPr>
-          <p:cNvPr id="22" name="TextBox 22"/>
-          <p:cNvSpPr txBox="1"/>
-          <p:nvPr/>
-        </p:nvSpPr>
-        <p:spPr>
-          <a:xfrm>
-            <a:off x="13323735" y="1786572"/>
-            <a:ext cx="1433134" cy="323215"/>
-          </a:xfrm>
-          <a:prstGeom prst="rect">
-            <a:avLst/>
-          </a:prstGeom>
-        </p:spPr>
-        <p:txBody>
-          <a:bodyPr lIns="0" tIns="0" rIns="0" bIns="0" rtlCol="0" anchor="t">
-            <a:spAutoFit/>
-          </a:bodyPr>
-          <a:lstStyle/>
-          <a:p>
-            <a:pPr algn="ctr">
-              <a:lnSpc>
-                <a:spcPts val="2659"/>
-              </a:lnSpc>
-              <a:spcBef>
-                <a:spcPct val="0"/>
-              </a:spcBef>
-            </a:pPr>
-            <a:r>
-              <a:rPr lang="en-US" sz="1899">
-                <a:solidFill>
-                  <a:srgbClr val="000000"/>
-                </a:solidFill>
-                <a:latin typeface="Anton"/>
-                <a:ea typeface="Anton"/>
-                <a:cs typeface="Anton"/>
-                <a:sym typeface="Anton"/>
-              </a:rPr>
-              <a:t>BLOCK DIAGRAM</a:t>
-            </a:r>
-          </a:p>
-        </p:txBody>
-      </p:sp>
-      <p:sp>
-        <p:nvSpPr>
-          <p:cNvPr id="23" name="TextBox 23"/>
-          <p:cNvSpPr txBox="1"/>
-          <p:nvPr/>
-        </p:nvSpPr>
-        <p:spPr>
-          <a:xfrm>
-            <a:off x="13481761" y="2008664"/>
-            <a:ext cx="1386721" cy="323215"/>
-          </a:xfrm>
-          <a:prstGeom prst="rect">
-            <a:avLst/>
-          </a:prstGeom>
-        </p:spPr>
-        <p:txBody>
-          <a:bodyPr lIns="0" tIns="0" rIns="0" bIns="0" rtlCol="0" anchor="t">
-            <a:spAutoFit/>
-          </a:bodyPr>
-          <a:lstStyle/>
-          <a:p>
-            <a:pPr algn="ctr">
-              <a:lnSpc>
-                <a:spcPts val="2659"/>
-              </a:lnSpc>
-              <a:spcBef>
-                <a:spcPct val="0"/>
-              </a:spcBef>
-            </a:pPr>
-            <a:r>
-              <a:rPr lang="en-US" sz="1899">
-                <a:solidFill>
-                  <a:srgbClr val="FFFFFF"/>
-                </a:solidFill>
-                <a:latin typeface="Anton"/>
-                <a:ea typeface="Anton"/>
-                <a:cs typeface="Anton"/>
-                <a:sym typeface="Anton"/>
-              </a:rPr>
-              <a:t>Block Diagram</a:t>
-            </a:r>
-          </a:p>
-        </p:txBody>
-      </p:sp>
+      </p:pic>
     </p:spTree>
   </p:cSld>
   <p:clrMapOvr>
@@ -6712,6 +6623,89 @@
       </p:grpSpPr>
       <p:grpSp>
         <p:nvGrpSpPr>
+          <p:cNvPr id="11" name="Group 11"/>
+          <p:cNvGrpSpPr/>
+          <p:nvPr/>
+        </p:nvGrpSpPr>
+        <p:grpSpPr>
+          <a:xfrm>
+            <a:off x="0" y="9174189"/>
+            <a:ext cx="3003140" cy="1112811"/>
+            <a:chOff x="0" y="0"/>
+            <a:chExt cx="1364325" cy="1021343"/>
+          </a:xfrm>
+        </p:grpSpPr>
+        <p:sp>
+          <p:nvSpPr>
+            <p:cNvPr id="12" name="Freeform 12"/>
+            <p:cNvSpPr/>
+            <p:nvPr/>
+          </p:nvSpPr>
+          <p:spPr>
+            <a:xfrm>
+              <a:off x="0" y="0"/>
+              <a:ext cx="1364325" cy="1021343"/>
+            </a:xfrm>
+            <a:custGeom>
+              <a:avLst/>
+              <a:gdLst/>
+              <a:ahLst/>
+              <a:cxnLst/>
+              <a:rect l="l" t="t" r="r" b="b"/>
+              <a:pathLst>
+                <a:path w="1364325" h="1021343">
+                  <a:moveTo>
+                    <a:pt x="0" y="0"/>
+                  </a:moveTo>
+                  <a:lnTo>
+                    <a:pt x="1364325" y="0"/>
+                  </a:lnTo>
+                  <a:lnTo>
+                    <a:pt x="1364325" y="1021343"/>
+                  </a:lnTo>
+                  <a:lnTo>
+                    <a:pt x="0" y="1021343"/>
+                  </a:lnTo>
+                  <a:close/>
+                </a:path>
+              </a:pathLst>
+            </a:custGeom>
+            <a:solidFill>
+              <a:srgbClr val="FFFFFF"/>
+            </a:solidFill>
+          </p:spPr>
+        </p:sp>
+        <p:sp>
+          <p:nvSpPr>
+            <p:cNvPr id="13" name="TextBox 13"/>
+            <p:cNvSpPr txBox="1"/>
+            <p:nvPr/>
+          </p:nvSpPr>
+          <p:spPr>
+            <a:xfrm>
+              <a:off x="0" y="-38100"/>
+              <a:ext cx="1364325" cy="1059443"/>
+            </a:xfrm>
+            <a:prstGeom prst="rect">
+              <a:avLst/>
+            </a:prstGeom>
+          </p:spPr>
+          <p:txBody>
+            <a:bodyPr lIns="50800" tIns="50800" rIns="50800" bIns="50800" rtlCol="0" anchor="ctr"/>
+            <a:lstStyle/>
+            <a:p>
+              <a:pPr algn="ctr">
+                <a:lnSpc>
+                  <a:spcPts val="2659"/>
+                </a:lnSpc>
+              </a:pPr>
+              <a:endParaRPr/>
+            </a:p>
+          </p:txBody>
+        </p:sp>
+      </p:grpSp>
+      <p:grpSp>
+        <p:nvGrpSpPr>
           <p:cNvPr id="2" name="Group 2"/>
           <p:cNvGrpSpPr/>
           <p:nvPr/>
@@ -6719,7 +6713,7 @@
         <p:grpSpPr>
           <a:xfrm>
             <a:off x="6456586" y="9622915"/>
-            <a:ext cx="11318235" cy="8119607"/>
+            <a:ext cx="11318235" cy="664085"/>
             <a:chOff x="0" y="0"/>
             <a:chExt cx="1538503" cy="1103709"/>
           </a:xfrm>
@@ -6825,8 +6819,8 @@
         </p:nvGrpSpPr>
         <p:grpSpPr>
           <a:xfrm>
-            <a:off x="16148114" y="5149464"/>
-            <a:ext cx="3253413" cy="819920"/>
+            <a:off x="16148115" y="5149464"/>
+            <a:ext cx="2139886" cy="819920"/>
             <a:chOff x="0" y="0"/>
             <a:chExt cx="442241" cy="111453"/>
           </a:xfrm>
@@ -6978,89 +6972,6 @@
             <a:xfrm>
               <a:off x="0" y="-38100"/>
               <a:ext cx="116742" cy="149553"/>
-            </a:xfrm>
-            <a:prstGeom prst="rect">
-              <a:avLst/>
-            </a:prstGeom>
-          </p:spPr>
-          <p:txBody>
-            <a:bodyPr lIns="50800" tIns="50800" rIns="50800" bIns="50800" rtlCol="0" anchor="ctr"/>
-            <a:lstStyle/>
-            <a:p>
-              <a:pPr algn="ctr">
-                <a:lnSpc>
-                  <a:spcPts val="2659"/>
-                </a:lnSpc>
-              </a:pPr>
-              <a:endParaRPr/>
-            </a:p>
-          </p:txBody>
-        </p:sp>
-      </p:grpSp>
-      <p:grpSp>
-        <p:nvGrpSpPr>
-          <p:cNvPr id="11" name="Group 11"/>
-          <p:cNvGrpSpPr/>
-          <p:nvPr/>
-        </p:nvGrpSpPr>
-        <p:grpSpPr>
-          <a:xfrm>
-            <a:off x="-2177031" y="9174189"/>
-            <a:ext cx="5180171" cy="3877913"/>
-            <a:chOff x="0" y="0"/>
-            <a:chExt cx="1364325" cy="1021343"/>
-          </a:xfrm>
-        </p:grpSpPr>
-        <p:sp>
-          <p:nvSpPr>
-            <p:cNvPr id="12" name="Freeform 12"/>
-            <p:cNvSpPr/>
-            <p:nvPr/>
-          </p:nvSpPr>
-          <p:spPr>
-            <a:xfrm>
-              <a:off x="0" y="0"/>
-              <a:ext cx="1364325" cy="1021343"/>
-            </a:xfrm>
-            <a:custGeom>
-              <a:avLst/>
-              <a:gdLst/>
-              <a:ahLst/>
-              <a:cxnLst/>
-              <a:rect l="l" t="t" r="r" b="b"/>
-              <a:pathLst>
-                <a:path w="1364325" h="1021343">
-                  <a:moveTo>
-                    <a:pt x="0" y="0"/>
-                  </a:moveTo>
-                  <a:lnTo>
-                    <a:pt x="1364325" y="0"/>
-                  </a:lnTo>
-                  <a:lnTo>
-                    <a:pt x="1364325" y="1021343"/>
-                  </a:lnTo>
-                  <a:lnTo>
-                    <a:pt x="0" y="1021343"/>
-                  </a:lnTo>
-                  <a:close/>
-                </a:path>
-              </a:pathLst>
-            </a:custGeom>
-            <a:solidFill>
-              <a:srgbClr val="FFFFFF"/>
-            </a:solidFill>
-          </p:spPr>
-        </p:sp>
-        <p:sp>
-          <p:nvSpPr>
-            <p:cNvPr id="13" name="TextBox 13"/>
-            <p:cNvSpPr txBox="1"/>
-            <p:nvPr/>
-          </p:nvSpPr>
-          <p:spPr>
-            <a:xfrm>
-              <a:off x="0" y="-38100"/>
-              <a:ext cx="1364325" cy="1059443"/>
             </a:xfrm>
             <a:prstGeom prst="rect">
               <a:avLst/>
@@ -7260,14 +7171,115 @@
       </p:grpSp>
       <p:sp>
         <p:nvSpPr>
-          <p:cNvPr id="20" name="Freeform 20"/>
+          <p:cNvPr id="20" name="TextBox 20"/>
+          <p:cNvSpPr txBox="1"/>
+          <p:nvPr/>
+        </p:nvSpPr>
+        <p:spPr>
+          <a:xfrm>
+            <a:off x="797728" y="420240"/>
+            <a:ext cx="10171019" cy="1600229"/>
+          </a:xfrm>
+          <a:prstGeom prst="rect">
+            <a:avLst/>
+          </a:prstGeom>
+        </p:spPr>
+        <p:txBody>
+          <a:bodyPr lIns="0" tIns="0" rIns="0" bIns="0" rtlCol="0" anchor="t">
+            <a:spAutoFit/>
+          </a:bodyPr>
+          <a:lstStyle/>
+          <a:p>
+            <a:pPr algn="l">
+              <a:lnSpc>
+                <a:spcPts val="10715"/>
+              </a:lnSpc>
+            </a:pPr>
+            <a:r>
+              <a:rPr lang="en-US" sz="8179" b="1">
+                <a:solidFill>
+                  <a:srgbClr val="FFFFFF"/>
+                </a:solidFill>
+                <a:latin typeface="29LT Bukra Bold"/>
+                <a:ea typeface="29LT Bukra Bold"/>
+                <a:cs typeface="29LT Bukra Bold"/>
+                <a:sym typeface="29LT Bukra Bold"/>
+              </a:rPr>
+              <a:t>METHODOLOGY</a:t>
+            </a:r>
+          </a:p>
+        </p:txBody>
+      </p:sp>
+      <p:sp>
+        <p:nvSpPr>
+          <p:cNvPr id="21" name="TextBox 21"/>
+          <p:cNvSpPr txBox="1"/>
+          <p:nvPr/>
+        </p:nvSpPr>
+        <p:spPr>
+          <a:xfrm>
+            <a:off x="1909606" y="2651062"/>
+            <a:ext cx="7858737" cy="846323"/>
+          </a:xfrm>
+          <a:prstGeom prst="rect">
+            <a:avLst/>
+          </a:prstGeom>
+        </p:spPr>
+        <p:txBody>
+          <a:bodyPr lIns="0" tIns="0" rIns="0" bIns="0" rtlCol="0" anchor="t">
+            <a:spAutoFit/>
+          </a:bodyPr>
+          <a:lstStyle/>
+          <a:p>
+            <a:pPr algn="just">
+              <a:lnSpc>
+                <a:spcPts val="3421"/>
+              </a:lnSpc>
+            </a:pPr>
+            <a:r>
+              <a:rPr lang="en-US" sz="2592">
+                <a:solidFill>
+                  <a:srgbClr val="FFFFFF"/>
+                </a:solidFill>
+                <a:latin typeface="Body Text"/>
+                <a:ea typeface="Body Text"/>
+                <a:cs typeface="Body Text"/>
+                <a:sym typeface="Body Text"/>
+              </a:rPr>
+              <a:t>How you carried out your work or plan to carry it out</a:t>
+            </a:r>
+          </a:p>
+          <a:p>
+            <a:pPr algn="just">
+              <a:lnSpc>
+                <a:spcPts val="3421"/>
+              </a:lnSpc>
+            </a:pPr>
+            <a:r>
+              <a:rPr lang="en-US" sz="2592">
+                <a:solidFill>
+                  <a:srgbClr val="FFFFFF"/>
+                </a:solidFill>
+                <a:latin typeface="Body Text"/>
+                <a:ea typeface="Body Text"/>
+                <a:cs typeface="Body Text"/>
+                <a:sym typeface="Body Text"/>
+              </a:rPr>
+              <a:t>(Tech Stack/Project Architecture)</a:t>
+            </a:r>
+          </a:p>
+        </p:txBody>
+      </p:sp>
+      <p:sp>
+        <p:nvSpPr>
+          <p:cNvPr id="22" name="Freeform 22"/>
           <p:cNvSpPr/>
           <p:nvPr/>
         </p:nvSpPr>
         <p:spPr>
           <a:xfrm>
-            <a:off x="15942278" y="0"/>
-            <a:ext cx="2345722" cy="2345722"/>
+            <a:off x="15895863" y="0"/>
+            <a:ext cx="2321737" cy="2321737"/>
           </a:xfrm>
           <a:custGeom>
             <a:avLst/>
@@ -7276,18 +7288,18 @@
             <a:cxnLst/>
             <a:rect l="l" t="t" r="r" b="b"/>
             <a:pathLst>
-              <a:path w="2345722" h="2345722">
+              <a:path w="2321737" h="2321737">
                 <a:moveTo>
                   <a:pt x="0" y="0"/>
                 </a:moveTo>
                 <a:lnTo>
-                  <a:pt x="2345722" y="0"/>
+                  <a:pt x="2321737" y="0"/>
                 </a:lnTo>
                 <a:lnTo>
-                  <a:pt x="2345722" y="2345722"/>
+                  <a:pt x="2321737" y="2321737"/>
                 </a:lnTo>
                 <a:lnTo>
-                  <a:pt x="0" y="2345722"/>
+                  <a:pt x="0" y="2321737"/>
                 </a:lnTo>
                 <a:lnTo>
                   <a:pt x="0" y="0"/>
@@ -7303,107 +7315,6 @@
             </a:stretch>
           </a:blipFill>
         </p:spPr>
-      </p:sp>
-      <p:sp>
-        <p:nvSpPr>
-          <p:cNvPr id="21" name="TextBox 21"/>
-          <p:cNvSpPr txBox="1"/>
-          <p:nvPr/>
-        </p:nvSpPr>
-        <p:spPr>
-          <a:xfrm>
-            <a:off x="797728" y="420240"/>
-            <a:ext cx="10171019" cy="1600229"/>
-          </a:xfrm>
-          <a:prstGeom prst="rect">
-            <a:avLst/>
-          </a:prstGeom>
-        </p:spPr>
-        <p:txBody>
-          <a:bodyPr lIns="0" tIns="0" rIns="0" bIns="0" rtlCol="0" anchor="t">
-            <a:spAutoFit/>
-          </a:bodyPr>
-          <a:lstStyle/>
-          <a:p>
-            <a:pPr algn="l">
-              <a:lnSpc>
-                <a:spcPts val="10715"/>
-              </a:lnSpc>
-            </a:pPr>
-            <a:r>
-              <a:rPr lang="en-US" sz="8179" b="1">
-                <a:solidFill>
-                  <a:srgbClr val="FFFFFF"/>
-                </a:solidFill>
-                <a:latin typeface="29LT Bukra Bold"/>
-                <a:ea typeface="29LT Bukra Bold"/>
-                <a:cs typeface="29LT Bukra Bold"/>
-                <a:sym typeface="29LT Bukra Bold"/>
-              </a:rPr>
-              <a:t>METHODOLOGY</a:t>
-            </a:r>
-          </a:p>
-        </p:txBody>
-      </p:sp>
-      <p:sp>
-        <p:nvSpPr>
-          <p:cNvPr id="22" name="TextBox 22"/>
-          <p:cNvSpPr txBox="1"/>
-          <p:nvPr/>
-        </p:nvSpPr>
-        <p:spPr>
-          <a:xfrm>
-            <a:off x="1909606" y="2651062"/>
-            <a:ext cx="7858737" cy="846323"/>
-          </a:xfrm>
-          <a:prstGeom prst="rect">
-            <a:avLst/>
-          </a:prstGeom>
-        </p:spPr>
-        <p:txBody>
-          <a:bodyPr lIns="0" tIns="0" rIns="0" bIns="0" rtlCol="0" anchor="t">
-            <a:spAutoFit/>
-          </a:bodyPr>
-          <a:lstStyle/>
-          <a:p>
-            <a:pPr algn="just">
-              <a:lnSpc>
-                <a:spcPts val="3421"/>
-              </a:lnSpc>
-            </a:pPr>
-            <a:r>
-              <a:rPr lang="en-US" sz="2592">
-                <a:solidFill>
-                  <a:srgbClr val="FFFFFF"/>
-                </a:solidFill>
-                <a:latin typeface="Body Text"/>
-                <a:ea typeface="Body Text"/>
-                <a:cs typeface="Body Text"/>
-                <a:sym typeface="Body Text"/>
-              </a:rPr>
-              <a:t>How you carried out your work or plan to carry it out</a:t>
-            </a:r>
-          </a:p>
-          <a:p>
-            <a:pPr algn="just">
-              <a:lnSpc>
-                <a:spcPts val="3421"/>
-              </a:lnSpc>
-            </a:pPr>
-            <a:r>
-              <a:rPr lang="en-US" sz="2592">
-                <a:solidFill>
-                  <a:srgbClr val="FFFFFF"/>
-                </a:solidFill>
-                <a:latin typeface="Body Text"/>
-                <a:ea typeface="Body Text"/>
-                <a:cs typeface="Body Text"/>
-                <a:sym typeface="Body Text"/>
-              </a:rPr>
-              <a:t>(Tech Stack/Project Architecture)</a:t>
-            </a:r>
-          </a:p>
-        </p:txBody>
       </p:sp>
     </p:spTree>
   </p:cSld>
@@ -7450,58 +7361,6 @@
           <a:chExt cx="0" cy="0"/>
         </a:xfrm>
       </p:grpSpPr>
-      <p:sp>
-        <p:nvSpPr>
-          <p:cNvPr id="2" name="Freeform 2"/>
-          <p:cNvSpPr/>
-          <p:nvPr/>
-        </p:nvSpPr>
-        <p:spPr>
-          <a:xfrm>
-            <a:off x="16151672" y="9568277"/>
-            <a:ext cx="2743795" cy="692808"/>
-          </a:xfrm>
-          <a:custGeom>
-            <a:avLst/>
-            <a:gdLst/>
-            <a:ahLst/>
-            <a:cxnLst/>
-            <a:rect l="l" t="t" r="r" b="b"/>
-            <a:pathLst>
-              <a:path w="2743795" h="692808">
-                <a:moveTo>
-                  <a:pt x="0" y="0"/>
-                </a:moveTo>
-                <a:lnTo>
-                  <a:pt x="2743796" y="0"/>
-                </a:lnTo>
-                <a:lnTo>
-                  <a:pt x="2743796" y="692808"/>
-                </a:lnTo>
-                <a:lnTo>
-                  <a:pt x="0" y="692808"/>
-                </a:lnTo>
-                <a:lnTo>
-                  <a:pt x="0" y="0"/>
-                </a:lnTo>
-                <a:close/>
-              </a:path>
-            </a:pathLst>
-          </a:custGeom>
-          <a:blipFill>
-            <a:blip r:embed="rId2">
-              <a:extLst>
-                <a:ext uri="{96DAC541-7B7A-43D3-8B79-37D633B846F1}">
-                  <asvg:svgBlip xmlns:asvg="http://schemas.microsoft.com/office/drawing/2016/SVG/main" r:embed="rId3"/>
-                </a:ext>
-              </a:extLst>
-            </a:blip>
-            <a:stretch>
-              <a:fillRect/>
-            </a:stretch>
-          </a:blipFill>
-        </p:spPr>
-      </p:sp>
       <p:grpSp>
         <p:nvGrpSpPr>
           <p:cNvPr id="3" name="Group 3"/>
@@ -7510,7 +7369,7 @@
         </p:nvGrpSpPr>
         <p:grpSpPr>
           <a:xfrm>
-            <a:off x="9820558" y="9568277"/>
+            <a:off x="9134901" y="9594192"/>
             <a:ext cx="6708766" cy="718723"/>
             <a:chOff x="0" y="0"/>
             <a:chExt cx="1766918" cy="189293"/>
@@ -7596,7 +7455,7 @@
         </p:nvSpPr>
         <p:spPr>
           <a:xfrm>
-            <a:off x="16352912" y="9568277"/>
+            <a:off x="15469256" y="9594192"/>
             <a:ext cx="2743795" cy="692808"/>
           </a:xfrm>
           <a:custGeom>
@@ -7642,100 +7501,14 @@
       </p:sp>
       <p:grpSp>
         <p:nvGrpSpPr>
-          <p:cNvPr id="7" name="Group 7"/>
-          <p:cNvGrpSpPr/>
-          <p:nvPr/>
-        </p:nvGrpSpPr>
-        <p:grpSpPr>
-          <a:xfrm>
-            <a:off x="9820558" y="9542362"/>
-            <a:ext cx="6708766" cy="718723"/>
-            <a:chOff x="0" y="0"/>
-            <a:chExt cx="1766918" cy="189293"/>
-          </a:xfrm>
-        </p:grpSpPr>
-        <p:sp>
-          <p:nvSpPr>
-            <p:cNvPr id="8" name="Freeform 8"/>
-            <p:cNvSpPr/>
-            <p:nvPr/>
-          </p:nvSpPr>
-          <p:spPr>
-            <a:xfrm>
-              <a:off x="0" y="0"/>
-              <a:ext cx="1766918" cy="189293"/>
-            </a:xfrm>
-            <a:custGeom>
-              <a:avLst/>
-              <a:gdLst/>
-              <a:ahLst/>
-              <a:cxnLst/>
-              <a:rect l="l" t="t" r="r" b="b"/>
-              <a:pathLst>
-                <a:path w="1766918" h="189293">
-                  <a:moveTo>
-                    <a:pt x="203200" y="0"/>
-                  </a:moveTo>
-                  <a:lnTo>
-                    <a:pt x="1766918" y="0"/>
-                  </a:lnTo>
-                  <a:lnTo>
-                    <a:pt x="1563718" y="189293"/>
-                  </a:lnTo>
-                  <a:lnTo>
-                    <a:pt x="0" y="189293"/>
-                  </a:lnTo>
-                  <a:lnTo>
-                    <a:pt x="203200" y="0"/>
-                  </a:lnTo>
-                  <a:close/>
-                </a:path>
-              </a:pathLst>
-            </a:custGeom>
-            <a:solidFill>
-              <a:srgbClr val="FFFFFF"/>
-            </a:solidFill>
-          </p:spPr>
-        </p:sp>
-        <p:sp>
-          <p:nvSpPr>
-            <p:cNvPr id="9" name="TextBox 9"/>
-            <p:cNvSpPr txBox="1"/>
-            <p:nvPr/>
-          </p:nvSpPr>
-          <p:spPr>
-            <a:xfrm>
-              <a:off x="101600" y="-38100"/>
-              <a:ext cx="1563718" cy="227393"/>
-            </a:xfrm>
-            <a:prstGeom prst="rect">
-              <a:avLst/>
-            </a:prstGeom>
-          </p:spPr>
-          <p:txBody>
-            <a:bodyPr lIns="50800" tIns="50800" rIns="50800" bIns="50800" rtlCol="0" anchor="ctr"/>
-            <a:lstStyle/>
-            <a:p>
-              <a:pPr algn="ctr">
-                <a:lnSpc>
-                  <a:spcPts val="2659"/>
-                </a:lnSpc>
-              </a:pPr>
-              <a:endParaRPr/>
-            </a:p>
-          </p:txBody>
-        </p:sp>
-      </p:grpSp>
-      <p:grpSp>
-        <p:nvGrpSpPr>
           <p:cNvPr id="10" name="Group 10"/>
           <p:cNvGrpSpPr/>
           <p:nvPr/>
         </p:nvGrpSpPr>
         <p:grpSpPr>
           <a:xfrm>
-            <a:off x="-172053" y="2345722"/>
-            <a:ext cx="2681721" cy="289923"/>
+            <a:off x="0" y="2345722"/>
+            <a:ext cx="2509668" cy="435578"/>
             <a:chOff x="0" y="0"/>
             <a:chExt cx="601815" cy="65063"/>
           </a:xfrm>
@@ -7811,14 +7584,55 @@
       </p:grpSp>
       <p:sp>
         <p:nvSpPr>
-          <p:cNvPr id="13" name="Freeform 13"/>
+          <p:cNvPr id="13" name="TextBox 13"/>
+          <p:cNvSpPr txBox="1"/>
+          <p:nvPr/>
+        </p:nvSpPr>
+        <p:spPr>
+          <a:xfrm>
+            <a:off x="5934357" y="3763160"/>
+            <a:ext cx="6419286" cy="1380340"/>
+          </a:xfrm>
+          <a:prstGeom prst="rect">
+            <a:avLst/>
+          </a:prstGeom>
+        </p:spPr>
+        <p:txBody>
+          <a:bodyPr lIns="0" tIns="0" rIns="0" bIns="0" rtlCol="0" anchor="t">
+            <a:spAutoFit/>
+          </a:bodyPr>
+          <a:lstStyle/>
+          <a:p>
+            <a:pPr algn="l">
+              <a:lnSpc>
+                <a:spcPts val="9255"/>
+              </a:lnSpc>
+            </a:pPr>
+            <a:r>
+              <a:rPr lang="en-US" sz="7065" b="1">
+                <a:solidFill>
+                  <a:srgbClr val="FFFFFF"/>
+                </a:solidFill>
+                <a:latin typeface="29LT Bukra Bold"/>
+                <a:ea typeface="29LT Bukra Bold"/>
+                <a:cs typeface="29LT Bukra Bold"/>
+                <a:sym typeface="29LT Bukra Bold"/>
+              </a:rPr>
+              <a:t>THANK YOU</a:t>
+            </a:r>
+          </a:p>
+        </p:txBody>
+      </p:sp>
+      <p:sp>
+        <p:nvSpPr>
+          <p:cNvPr id="14" name="Freeform 14"/>
           <p:cNvSpPr/>
           <p:nvPr/>
         </p:nvSpPr>
         <p:spPr>
           <a:xfrm>
-            <a:off x="15942278" y="0"/>
-            <a:ext cx="2345722" cy="2345722"/>
+            <a:off x="15895863" y="0"/>
+            <a:ext cx="2321737" cy="2321737"/>
           </a:xfrm>
           <a:custGeom>
             <a:avLst/>
@@ -7827,18 +7641,18 @@
             <a:cxnLst/>
             <a:rect l="l" t="t" r="r" b="b"/>
             <a:pathLst>
-              <a:path w="2345722" h="2345722">
+              <a:path w="2321737" h="2321737">
                 <a:moveTo>
                   <a:pt x="0" y="0"/>
                 </a:moveTo>
                 <a:lnTo>
-                  <a:pt x="2345722" y="0"/>
+                  <a:pt x="2321737" y="0"/>
                 </a:lnTo>
                 <a:lnTo>
-                  <a:pt x="2345722" y="2345722"/>
+                  <a:pt x="2321737" y="2321737"/>
                 </a:lnTo>
                 <a:lnTo>
-                  <a:pt x="0" y="2345722"/>
+                  <a:pt x="0" y="2321737"/>
                 </a:lnTo>
                 <a:lnTo>
                   <a:pt x="0" y="0"/>
@@ -7854,79 +7668,6 @@
             </a:stretch>
           </a:blipFill>
         </p:spPr>
-      </p:sp>
-      <p:sp>
-        <p:nvSpPr>
-          <p:cNvPr id="14" name="TextBox 14"/>
-          <p:cNvSpPr txBox="1"/>
-          <p:nvPr/>
-        </p:nvSpPr>
-        <p:spPr>
-          <a:xfrm>
-            <a:off x="5538986" y="-979923"/>
-            <a:ext cx="13157369" cy="6607837"/>
-          </a:xfrm>
-          <a:prstGeom prst="rect">
-            <a:avLst/>
-          </a:prstGeom>
-        </p:spPr>
-        <p:txBody>
-          <a:bodyPr lIns="0" tIns="0" rIns="0" bIns="0" rtlCol="0" anchor="t">
-            <a:spAutoFit/>
-          </a:bodyPr>
-          <a:lstStyle/>
-          <a:p>
-            <a:pPr algn="l">
-              <a:lnSpc>
-                <a:spcPts val="10060"/>
-              </a:lnSpc>
-            </a:pPr>
-            <a:endParaRPr/>
-          </a:p>
-          <a:p>
-            <a:pPr algn="l">
-              <a:lnSpc>
-                <a:spcPts val="10060"/>
-              </a:lnSpc>
-            </a:pPr>
-            <a:endParaRPr/>
-          </a:p>
-          <a:p>
-            <a:pPr algn="l">
-              <a:lnSpc>
-                <a:spcPts val="10060"/>
-              </a:lnSpc>
-            </a:pPr>
-            <a:endParaRPr/>
-          </a:p>
-          <a:p>
-            <a:pPr algn="l">
-              <a:lnSpc>
-                <a:spcPts val="10060"/>
-              </a:lnSpc>
-            </a:pPr>
-            <a:endParaRPr/>
-          </a:p>
-          <a:p>
-            <a:pPr algn="l">
-              <a:lnSpc>
-                <a:spcPts val="10060"/>
-              </a:lnSpc>
-            </a:pPr>
-            <a:r>
-              <a:rPr lang="en-US" sz="7679" b="1">
-                <a:solidFill>
-                  <a:srgbClr val="FFFFFF"/>
-                </a:solidFill>
-                <a:latin typeface="29LT Bukra Bold"/>
-                <a:ea typeface="29LT Bukra Bold"/>
-                <a:cs typeface="29LT Bukra Bold"/>
-                <a:sym typeface="29LT Bukra Bold"/>
-              </a:rPr>
-              <a:t>THANK YOU</a:t>
-            </a:r>
-          </a:p>
-        </p:txBody>
       </p:sp>
     </p:spTree>
   </p:cSld>

</xml_diff>